<commit_message>
vault backup: 2026-08-07 13:21:38
</commit_message>
<xml_diff>
--- a/큐알스탬프 소개서/QR솔루션_소개서_v5.pptx
+++ b/큐알스탬프 소개서/QR솔루션_소개서_v5.pptx
@@ -3147,54 +3147,30 @@
           </a:p>
         </p:txBody>
       </p:sp>
-      <p:sp>
-        <p:nvSpPr>
-          <p:cNvPr id="3" name="Rounded Rectangle 2"/>
-          <p:cNvSpPr/>
-          <p:nvPr/>
-        </p:nvSpPr>
-        <p:spPr>
-          <a:xfrm>
-            <a:off x="762000" y="635000"/>
-            <a:ext cx="1270000" cy="368300"/>
-          </a:xfrm>
-          <a:prstGeom prst="roundRect">
-            <a:avLst>
-              <a:gd name="adj" fmla="val 6896"/>
-            </a:avLst>
-          </a:prstGeom>
-          <a:solidFill>
-            <a:srgbClr val="FFFFFF"/>
-          </a:solidFill>
-          <a:ln w="6350">
-            <a:solidFill>
-              <a:srgbClr val="111315"/>
-            </a:solidFill>
-          </a:ln>
-          <a:effectLst/>
-        </p:spPr>
-        <p:style>
-          <a:lnRef idx="1">
-            <a:schemeClr val="accent1"/>
-          </a:lnRef>
-          <a:fillRef idx="3">
-            <a:schemeClr val="accent1"/>
-          </a:fillRef>
-          <a:effectRef idx="2">
-            <a:schemeClr val="accent1"/>
-          </a:effectRef>
-          <a:fontRef idx="minor">
-            <a:schemeClr val="lt1"/>
-          </a:fontRef>
-        </p:style>
-        <p:txBody>
-          <a:bodyPr rtlCol="0" anchor="ctr"/>
-          <a:lstStyle/>
-          <a:p>
-            <a:pPr algn="ctr"/>
-          </a:p>
-        </p:txBody>
-      </p:sp>
+      <p:pic>
+        <p:nvPicPr>
+          <p:cNvPr id="3" name="Picture 2" descr="logo.png"/>
+          <p:cNvPicPr>
+            <a:picLocks noChangeAspect="1"/>
+          </p:cNvPicPr>
+          <p:nvPr/>
+        </p:nvPicPr>
+        <p:blipFill>
+          <a:blip r:embed="rId2"/>
+          <a:stretch>
+            <a:fillRect/>
+          </a:stretch>
+        </p:blipFill>
+        <p:spPr>
+          <a:xfrm>
+            <a:off x="762000" y="723900"/>
+            <a:ext cx="889000" cy="298450"/>
+          </a:xfrm>
+          <a:prstGeom prst="rect">
+            <a:avLst/>
+          </a:prstGeom>
+        </p:spPr>
+      </p:pic>
       <p:sp>
         <p:nvSpPr>
           <p:cNvPr id="4" name="TextBox 3"/>
@@ -3203,27 +3179,27 @@
         </p:nvSpPr>
         <p:spPr>
           <a:xfrm>
-            <a:off x="838200" y="753110"/>
-            <a:ext cx="1117600" cy="182880"/>
-          </a:xfrm>
-          <a:prstGeom prst="rect">
-            <a:avLst/>
-          </a:prstGeom>
-          <a:noFill/>
-        </p:spPr>
-        <p:txBody>
-          <a:bodyPr wrap="square" lIns="0" rIns="0" tIns="0" bIns="0" anchor="t">
-            <a:spAutoFit/>
-          </a:bodyPr>
-          <a:lstStyle/>
-          <a:p>
-            <a:pPr algn="ctr">
-              <a:lnSpc>
-                <a:spcPct val="160000"/>
-              </a:lnSpc>
-            </a:pPr>
-            <a:r>
-              <a:rPr sz="650" b="0" spc="-6">
+            <a:off x="762000" y="1403350"/>
+            <a:ext cx="5715000" cy="1270000"/>
+          </a:xfrm>
+          <a:prstGeom prst="rect">
+            <a:avLst/>
+          </a:prstGeom>
+          <a:noFill/>
+        </p:spPr>
+        <p:txBody>
+          <a:bodyPr wrap="square" lIns="0" rIns="0" tIns="0" bIns="0" anchor="t">
+            <a:spAutoFit/>
+          </a:bodyPr>
+          <a:lstStyle/>
+          <a:p>
+            <a:pPr algn="l">
+              <a:lnSpc>
+                <a:spcPct val="120000"/>
+              </a:lnSpc>
+            </a:pPr>
+            <a:r>
+              <a:rPr sz="4000" b="1" spc="-40">
                 <a:solidFill>
                   <a:srgbClr val="111315"/>
                 </a:solidFill>
@@ -3232,7 +3208,26 @@
                 <a:ea typeface="Pretendard"/>
                 <a:cs typeface="Pretendard"/>
               </a:rPr>
-              <a:t>MAKEVU 로고</a:t>
+              <a:t>메이크뷰</a:t>
+            </a:r>
+          </a:p>
+          <a:p>
+            <a:pPr algn="l">
+              <a:lnSpc>
+                <a:spcPct val="120000"/>
+              </a:lnSpc>
+            </a:pPr>
+            <a:r>
+              <a:rPr sz="4000" b="1" spc="-40">
+                <a:solidFill>
+                  <a:srgbClr val="111315"/>
+                </a:solidFill>
+                <a:latin typeface="Pretendard"/>
+                <a:latin typeface="Pretendard"/>
+                <a:ea typeface="Pretendard"/>
+                <a:cs typeface="Pretendard"/>
+              </a:rPr>
+              <a:t>QR 스탬프 솔루션</a:t>
             </a:r>
           </a:p>
         </p:txBody>
@@ -3245,27 +3240,69 @@
         </p:nvSpPr>
         <p:spPr>
           <a:xfrm>
-            <a:off x="6350000" y="762000"/>
-            <a:ext cx="5080000" cy="212725"/>
-          </a:xfrm>
-          <a:prstGeom prst="rect">
-            <a:avLst/>
-          </a:prstGeom>
-          <a:noFill/>
-        </p:spPr>
-        <p:txBody>
-          <a:bodyPr wrap="square" lIns="0" rIns="0" tIns="0" bIns="0" anchor="t">
-            <a:spAutoFit/>
-          </a:bodyPr>
-          <a:lstStyle/>
-          <a:p>
-            <a:pPr algn="r">
+            <a:off x="762000" y="2876550"/>
+            <a:ext cx="5715000" cy="336550"/>
+          </a:xfrm>
+          <a:prstGeom prst="rect">
+            <a:avLst/>
+          </a:prstGeom>
+          <a:noFill/>
+        </p:spPr>
+        <p:txBody>
+          <a:bodyPr wrap="square" lIns="0" rIns="0" tIns="0" bIns="0" anchor="t">
+            <a:spAutoFit/>
+          </a:bodyPr>
+          <a:lstStyle/>
+          <a:p>
+            <a:pPr algn="l">
               <a:lnSpc>
                 <a:spcPct val="150000"/>
               </a:lnSpc>
             </a:pPr>
             <a:r>
-              <a:rPr sz="850" b="0" spc="-8">
+              <a:rPr sz="1500" b="0" spc="-15">
+                <a:solidFill>
+                  <a:srgbClr val="5A6169"/>
+                </a:solidFill>
+                <a:latin typeface="Pretendard"/>
+                <a:latin typeface="Pretendard"/>
+                <a:ea typeface="Pretendard"/>
+                <a:cs typeface="Pretendard"/>
+              </a:rPr>
+              <a:t>축제 · 팝업 · 박람회를 위한 앱 없는 QR 스탬프 투어</a:t>
+            </a:r>
+          </a:p>
+        </p:txBody>
+      </p:sp>
+      <p:sp>
+        <p:nvSpPr>
+          <p:cNvPr id="6" name="TextBox 5"/>
+          <p:cNvSpPr txBox="1"/>
+          <p:nvPr/>
+        </p:nvSpPr>
+        <p:spPr>
+          <a:xfrm>
+            <a:off x="762000" y="5969000"/>
+            <a:ext cx="5080000" cy="241300"/>
+          </a:xfrm>
+          <a:prstGeom prst="rect">
+            <a:avLst/>
+          </a:prstGeom>
+          <a:noFill/>
+        </p:spPr>
+        <p:txBody>
+          <a:bodyPr wrap="square" lIns="0" rIns="0" tIns="0" bIns="0" anchor="t">
+            <a:spAutoFit/>
+          </a:bodyPr>
+          <a:lstStyle/>
+          <a:p>
+            <a:pPr algn="l">
+              <a:lnSpc>
+                <a:spcPct val="150000"/>
+              </a:lnSpc>
+            </a:pPr>
+            <a:r>
+              <a:rPr sz="1000" b="0" spc="-10">
                 <a:solidFill>
                   <a:srgbClr val="8A9199"/>
                 </a:solidFill>
@@ -3279,283 +3316,30 @@
           </a:p>
         </p:txBody>
       </p:sp>
-      <p:sp>
-        <p:nvSpPr>
-          <p:cNvPr id="6" name="TextBox 5"/>
-          <p:cNvSpPr txBox="1"/>
-          <p:nvPr/>
-        </p:nvSpPr>
-        <p:spPr>
-          <a:xfrm>
-            <a:off x="762000" y="2514600"/>
-            <a:ext cx="5715000" cy="212725"/>
-          </a:xfrm>
-          <a:prstGeom prst="rect">
-            <a:avLst/>
-          </a:prstGeom>
-          <a:noFill/>
-        </p:spPr>
-        <p:txBody>
-          <a:bodyPr wrap="square" lIns="0" rIns="0" tIns="0" bIns="0" anchor="t">
-            <a:spAutoFit/>
-          </a:bodyPr>
-          <a:lstStyle/>
-          <a:p>
-            <a:pPr algn="l">
-              <a:lnSpc>
-                <a:spcPct val="150000"/>
-              </a:lnSpc>
-            </a:pPr>
-            <a:r>
-              <a:rPr sz="850" b="1" spc="34">
-                <a:solidFill>
-                  <a:srgbClr val="4B73FF"/>
-                </a:solidFill>
-                <a:latin typeface="Pretendard"/>
-                <a:latin typeface="Pretendard"/>
-                <a:ea typeface="Pretendard"/>
-                <a:cs typeface="Pretendard"/>
-              </a:rPr>
-              <a:t>COMPANY INTRODUCTION</a:t>
-            </a:r>
-          </a:p>
-        </p:txBody>
-      </p:sp>
-      <p:sp>
-        <p:nvSpPr>
-          <p:cNvPr id="7" name="TextBox 6"/>
-          <p:cNvSpPr txBox="1"/>
-          <p:nvPr/>
-        </p:nvSpPr>
-        <p:spPr>
-          <a:xfrm>
-            <a:off x="762000" y="2819400"/>
-            <a:ext cx="5715000" cy="1554988"/>
-          </a:xfrm>
-          <a:prstGeom prst="rect">
-            <a:avLst/>
-          </a:prstGeom>
-          <a:noFill/>
-        </p:spPr>
-        <p:txBody>
-          <a:bodyPr wrap="square" lIns="0" rIns="0" tIns="0" bIns="0" anchor="t">
-            <a:spAutoFit/>
-          </a:bodyPr>
-          <a:lstStyle/>
-          <a:p>
-            <a:pPr algn="l">
-              <a:lnSpc>
-                <a:spcPct val="126000"/>
-              </a:lnSpc>
-            </a:pPr>
-            <a:r>
-              <a:rPr sz="4700" b="1" spc="-47">
-                <a:solidFill>
-                  <a:srgbClr val="111315"/>
-                </a:solidFill>
-                <a:latin typeface="Pretendard"/>
-                <a:latin typeface="Pretendard"/>
-                <a:ea typeface="Pretendard"/>
-                <a:cs typeface="Pretendard"/>
-              </a:rPr>
-              <a:t>메이크뷰</a:t>
-            </a:r>
-          </a:p>
-          <a:p>
-            <a:pPr algn="l">
-              <a:lnSpc>
-                <a:spcPct val="126000"/>
-              </a:lnSpc>
-            </a:pPr>
-            <a:r>
-              <a:rPr sz="4700" b="1" spc="-47">
-                <a:solidFill>
-                  <a:srgbClr val="111315"/>
-                </a:solidFill>
-                <a:latin typeface="Pretendard"/>
-                <a:latin typeface="Pretendard"/>
-                <a:ea typeface="Pretendard"/>
-                <a:cs typeface="Pretendard"/>
-              </a:rPr>
-              <a:t>QR 솔루션</a:t>
-            </a:r>
-          </a:p>
-        </p:txBody>
-      </p:sp>
-      <p:sp>
-        <p:nvSpPr>
-          <p:cNvPr id="8" name="TextBox 7"/>
-          <p:cNvSpPr txBox="1"/>
-          <p:nvPr/>
-        </p:nvSpPr>
-        <p:spPr>
-          <a:xfrm>
-            <a:off x="762000" y="4635500"/>
-            <a:ext cx="5715000" cy="336550"/>
-          </a:xfrm>
-          <a:prstGeom prst="rect">
-            <a:avLst/>
-          </a:prstGeom>
-          <a:noFill/>
-        </p:spPr>
-        <p:txBody>
-          <a:bodyPr wrap="square" lIns="0" rIns="0" tIns="0" bIns="0" anchor="t">
-            <a:spAutoFit/>
-          </a:bodyPr>
-          <a:lstStyle/>
-          <a:p>
-            <a:pPr algn="l">
-              <a:lnSpc>
-                <a:spcPct val="150000"/>
-              </a:lnSpc>
-            </a:pPr>
-            <a:r>
-              <a:rPr sz="1500" b="0" spc="-15">
-                <a:solidFill>
-                  <a:srgbClr val="5A6169"/>
-                </a:solidFill>
-                <a:latin typeface="Pretendard"/>
-                <a:latin typeface="Pretendard"/>
-                <a:ea typeface="Pretendard"/>
-                <a:cs typeface="Pretendard"/>
-              </a:rPr>
-              <a:t>축제 · 팝업 · 박람회를 위한 앱 없는 QR 스탬프 투어</a:t>
-            </a:r>
-          </a:p>
-        </p:txBody>
-      </p:sp>
-      <p:sp>
-        <p:nvSpPr>
-          <p:cNvPr id="9" name="TextBox 8"/>
-          <p:cNvSpPr txBox="1"/>
-          <p:nvPr/>
-        </p:nvSpPr>
-        <p:spPr>
-          <a:xfrm>
-            <a:off x="762000" y="4991100"/>
-            <a:ext cx="5715000" cy="250825"/>
-          </a:xfrm>
-          <a:prstGeom prst="rect">
-            <a:avLst/>
-          </a:prstGeom>
-          <a:noFill/>
-        </p:spPr>
-        <p:txBody>
-          <a:bodyPr wrap="square" lIns="0" rIns="0" tIns="0" bIns="0" anchor="t">
-            <a:spAutoFit/>
-          </a:bodyPr>
-          <a:lstStyle/>
-          <a:p>
-            <a:pPr algn="l">
-              <a:lnSpc>
-                <a:spcPct val="150000"/>
-              </a:lnSpc>
-            </a:pPr>
-            <a:r>
-              <a:rPr sz="1050" b="1" spc="-10">
-                <a:solidFill>
-                  <a:srgbClr val="4B73FF"/>
-                </a:solidFill>
-                <a:latin typeface="Pretendard"/>
-                <a:latin typeface="Pretendard"/>
-                <a:ea typeface="Pretendard"/>
-                <a:cs typeface="Pretendard"/>
-              </a:rPr>
-              <a:t>평균 2~3일 제작  ·  QR 스캔 즉시 참여</a:t>
-            </a:r>
-          </a:p>
-        </p:txBody>
-      </p:sp>
-      <p:sp>
-        <p:nvSpPr>
-          <p:cNvPr id="10" name="Rounded Rectangle 9"/>
-          <p:cNvSpPr/>
-          <p:nvPr/>
-        </p:nvSpPr>
-        <p:spPr>
-          <a:xfrm>
-            <a:off x="6350000" y="1206500"/>
-            <a:ext cx="5080000" cy="4445000"/>
-          </a:xfrm>
-          <a:prstGeom prst="roundRect">
-            <a:avLst>
-              <a:gd name="adj" fmla="val 2571"/>
-            </a:avLst>
-          </a:prstGeom>
-          <a:solidFill>
-            <a:srgbClr val="F2F4F6"/>
-          </a:solidFill>
-          <a:ln w="6350">
-            <a:solidFill>
-              <a:srgbClr val="DCE1E6"/>
-            </a:solidFill>
-          </a:ln>
-          <a:effectLst/>
-        </p:spPr>
-        <p:style>
-          <a:lnRef idx="1">
-            <a:schemeClr val="accent1"/>
-          </a:lnRef>
-          <a:fillRef idx="3">
-            <a:schemeClr val="accent1"/>
-          </a:fillRef>
-          <a:effectRef idx="2">
-            <a:schemeClr val="accent1"/>
-          </a:effectRef>
-          <a:fontRef idx="minor">
-            <a:schemeClr val="lt1"/>
-          </a:fontRef>
-        </p:style>
-        <p:txBody>
-          <a:bodyPr rtlCol="0" anchor="ctr"/>
-          <a:lstStyle/>
-          <a:p>
-            <a:pPr algn="ctr"/>
-          </a:p>
-        </p:txBody>
-      </p:sp>
-      <p:sp>
-        <p:nvSpPr>
-          <p:cNvPr id="11" name="TextBox 10"/>
-          <p:cNvSpPr txBox="1"/>
-          <p:nvPr/>
-        </p:nvSpPr>
-        <p:spPr>
-          <a:xfrm>
-            <a:off x="6426200" y="3357880"/>
-            <a:ext cx="4927600" cy="193040"/>
-          </a:xfrm>
-          <a:prstGeom prst="rect">
-            <a:avLst/>
-          </a:prstGeom>
-          <a:noFill/>
-        </p:spPr>
-        <p:txBody>
-          <a:bodyPr wrap="square" lIns="0" rIns="0" tIns="0" bIns="0" anchor="t">
-            <a:spAutoFit/>
-          </a:bodyPr>
-          <a:lstStyle/>
-          <a:p>
-            <a:pPr algn="ctr">
-              <a:lnSpc>
-                <a:spcPct val="160000"/>
-              </a:lnSpc>
-            </a:pPr>
-            <a:r>
-              <a:rPr sz="700" b="0" spc="-7">
-                <a:solidFill>
-                  <a:srgbClr val="9AA1A9"/>
-                </a:solidFill>
-                <a:latin typeface="Pretendard"/>
-                <a:latin typeface="Pretendard"/>
-                <a:ea typeface="Pretendard"/>
-                <a:cs typeface="Pretendard"/>
-              </a:rPr>
-              <a:t>히어로 이미지 — 대문 영상 스틸 / 폰 목업</a:t>
-            </a:r>
-          </a:p>
-        </p:txBody>
-      </p:sp>
+      <p:pic>
+        <p:nvPicPr>
+          <p:cNvPr id="7" name="Picture 6" descr="hero.png"/>
+          <p:cNvPicPr>
+            <a:picLocks noChangeAspect="1"/>
+          </p:cNvPicPr>
+          <p:nvPr/>
+        </p:nvPicPr>
+        <p:blipFill>
+          <a:blip r:embed="rId3"/>
+          <a:stretch>
+            <a:fillRect/>
+          </a:stretch>
+        </p:blipFill>
+        <p:spPr>
+          <a:xfrm>
+            <a:off x="5054600" y="1504950"/>
+            <a:ext cx="7137400" cy="4654550"/>
+          </a:xfrm>
+          <a:prstGeom prst="rect">
+            <a:avLst/>
+          </a:prstGeom>
+        </p:spPr>
+      </p:pic>
     </p:spTree>
   </p:cSld>
   <p:clrMapOvr>
@@ -16551,1266 +16335,30 @@
           </a:p>
         </p:txBody>
       </p:sp>
-      <p:sp>
-        <p:nvSpPr>
-          <p:cNvPr id="9" name="Rounded Rectangle 8"/>
-          <p:cNvSpPr/>
-          <p:nvPr/>
-        </p:nvSpPr>
-        <p:spPr>
-          <a:xfrm>
-            <a:off x="762000" y="2984500"/>
-            <a:ext cx="2032000" cy="889000"/>
-          </a:xfrm>
-          <a:prstGeom prst="roundRect">
-            <a:avLst>
-              <a:gd name="adj" fmla="val 7142"/>
-            </a:avLst>
-          </a:prstGeom>
-          <a:solidFill>
-            <a:srgbClr val="F7F8FA"/>
-          </a:solidFill>
-          <a:ln w="6350">
-            <a:solidFill>
-              <a:srgbClr val="EDEFF2"/>
-            </a:solidFill>
-          </a:ln>
-          <a:effectLst/>
-        </p:spPr>
-        <p:style>
-          <a:lnRef idx="1">
-            <a:schemeClr val="accent1"/>
-          </a:lnRef>
-          <a:fillRef idx="3">
-            <a:schemeClr val="accent1"/>
-          </a:fillRef>
-          <a:effectRef idx="2">
-            <a:schemeClr val="accent1"/>
-          </a:effectRef>
-          <a:fontRef idx="minor">
-            <a:schemeClr val="lt1"/>
-          </a:fontRef>
-        </p:style>
-        <p:txBody>
-          <a:bodyPr rtlCol="0" anchor="ctr"/>
-          <a:lstStyle/>
-          <a:p>
-            <a:pPr algn="ctr"/>
-          </a:p>
-        </p:txBody>
-      </p:sp>
-      <p:sp>
-        <p:nvSpPr>
-          <p:cNvPr id="10" name="TextBox 9"/>
-          <p:cNvSpPr txBox="1"/>
-          <p:nvPr/>
-        </p:nvSpPr>
-        <p:spPr>
-          <a:xfrm>
-            <a:off x="838200" y="3347720"/>
-            <a:ext cx="1879600" cy="213360"/>
-          </a:xfrm>
-          <a:prstGeom prst="rect">
-            <a:avLst/>
-          </a:prstGeom>
-          <a:noFill/>
-        </p:spPr>
-        <p:txBody>
-          <a:bodyPr wrap="square" lIns="0" rIns="0" tIns="0" bIns="0" anchor="t">
-            <a:spAutoFit/>
-          </a:bodyPr>
-          <a:lstStyle/>
-          <a:p>
-            <a:pPr algn="ctr">
-              <a:lnSpc>
-                <a:spcPct val="160000"/>
-              </a:lnSpc>
-            </a:pPr>
-            <a:r>
-              <a:rPr sz="800" b="0" spc="-8">
-                <a:solidFill>
-                  <a:srgbClr val="AEB4BA"/>
-                </a:solidFill>
-                <a:latin typeface="Pretendard"/>
-                <a:latin typeface="Pretendard"/>
-                <a:ea typeface="Pretendard"/>
-                <a:cs typeface="Pretendard"/>
-              </a:rPr>
-              <a:t>롯데월드</a:t>
-            </a:r>
-          </a:p>
-        </p:txBody>
-      </p:sp>
-      <p:sp>
-        <p:nvSpPr>
-          <p:cNvPr id="11" name="Rounded Rectangle 10"/>
-          <p:cNvSpPr/>
-          <p:nvPr/>
-        </p:nvSpPr>
-        <p:spPr>
-          <a:xfrm>
-            <a:off x="2921000" y="2984500"/>
-            <a:ext cx="2032000" cy="889000"/>
-          </a:xfrm>
-          <a:prstGeom prst="roundRect">
-            <a:avLst>
-              <a:gd name="adj" fmla="val 7142"/>
-            </a:avLst>
-          </a:prstGeom>
-          <a:solidFill>
-            <a:srgbClr val="F7F8FA"/>
-          </a:solidFill>
-          <a:ln w="6350">
-            <a:solidFill>
-              <a:srgbClr val="EDEFF2"/>
-            </a:solidFill>
-          </a:ln>
-          <a:effectLst/>
-        </p:spPr>
-        <p:style>
-          <a:lnRef idx="1">
-            <a:schemeClr val="accent1"/>
-          </a:lnRef>
-          <a:fillRef idx="3">
-            <a:schemeClr val="accent1"/>
-          </a:fillRef>
-          <a:effectRef idx="2">
-            <a:schemeClr val="accent1"/>
-          </a:effectRef>
-          <a:fontRef idx="minor">
-            <a:schemeClr val="lt1"/>
-          </a:fontRef>
-        </p:style>
-        <p:txBody>
-          <a:bodyPr rtlCol="0" anchor="ctr"/>
-          <a:lstStyle/>
-          <a:p>
-            <a:pPr algn="ctr"/>
-          </a:p>
-        </p:txBody>
-      </p:sp>
-      <p:sp>
-        <p:nvSpPr>
-          <p:cNvPr id="12" name="TextBox 11"/>
-          <p:cNvSpPr txBox="1"/>
-          <p:nvPr/>
-        </p:nvSpPr>
-        <p:spPr>
-          <a:xfrm>
-            <a:off x="2997200" y="3347720"/>
-            <a:ext cx="1879600" cy="213360"/>
-          </a:xfrm>
-          <a:prstGeom prst="rect">
-            <a:avLst/>
-          </a:prstGeom>
-          <a:noFill/>
-        </p:spPr>
-        <p:txBody>
-          <a:bodyPr wrap="square" lIns="0" rIns="0" tIns="0" bIns="0" anchor="t">
-            <a:spAutoFit/>
-          </a:bodyPr>
-          <a:lstStyle/>
-          <a:p>
-            <a:pPr algn="ctr">
-              <a:lnSpc>
-                <a:spcPct val="160000"/>
-              </a:lnSpc>
-            </a:pPr>
-            <a:r>
-              <a:rPr sz="800" b="0" spc="-8">
-                <a:solidFill>
-                  <a:srgbClr val="AEB4BA"/>
-                </a:solidFill>
-                <a:latin typeface="Pretendard"/>
-                <a:latin typeface="Pretendard"/>
-                <a:ea typeface="Pretendard"/>
-                <a:cs typeface="Pretendard"/>
-              </a:rPr>
-              <a:t>워커힐</a:t>
-            </a:r>
-          </a:p>
-        </p:txBody>
-      </p:sp>
-      <p:sp>
-        <p:nvSpPr>
-          <p:cNvPr id="13" name="Rounded Rectangle 12"/>
-          <p:cNvSpPr/>
-          <p:nvPr/>
-        </p:nvSpPr>
-        <p:spPr>
-          <a:xfrm>
-            <a:off x="5080000" y="2984500"/>
-            <a:ext cx="2032000" cy="889000"/>
-          </a:xfrm>
-          <a:prstGeom prst="roundRect">
-            <a:avLst>
-              <a:gd name="adj" fmla="val 7142"/>
-            </a:avLst>
-          </a:prstGeom>
-          <a:solidFill>
-            <a:srgbClr val="F7F8FA"/>
-          </a:solidFill>
-          <a:ln w="6350">
-            <a:solidFill>
-              <a:srgbClr val="EDEFF2"/>
-            </a:solidFill>
-          </a:ln>
-          <a:effectLst/>
-        </p:spPr>
-        <p:style>
-          <a:lnRef idx="1">
-            <a:schemeClr val="accent1"/>
-          </a:lnRef>
-          <a:fillRef idx="3">
-            <a:schemeClr val="accent1"/>
-          </a:fillRef>
-          <a:effectRef idx="2">
-            <a:schemeClr val="accent1"/>
-          </a:effectRef>
-          <a:fontRef idx="minor">
-            <a:schemeClr val="lt1"/>
-          </a:fontRef>
-        </p:style>
-        <p:txBody>
-          <a:bodyPr rtlCol="0" anchor="ctr"/>
-          <a:lstStyle/>
-          <a:p>
-            <a:pPr algn="ctr"/>
-          </a:p>
-        </p:txBody>
-      </p:sp>
-      <p:sp>
-        <p:nvSpPr>
-          <p:cNvPr id="14" name="TextBox 13"/>
-          <p:cNvSpPr txBox="1"/>
-          <p:nvPr/>
-        </p:nvSpPr>
-        <p:spPr>
-          <a:xfrm>
-            <a:off x="5156200" y="3347720"/>
-            <a:ext cx="1879600" cy="213360"/>
-          </a:xfrm>
-          <a:prstGeom prst="rect">
-            <a:avLst/>
-          </a:prstGeom>
-          <a:noFill/>
-        </p:spPr>
-        <p:txBody>
-          <a:bodyPr wrap="square" lIns="0" rIns="0" tIns="0" bIns="0" anchor="t">
-            <a:spAutoFit/>
-          </a:bodyPr>
-          <a:lstStyle/>
-          <a:p>
-            <a:pPr algn="ctr">
-              <a:lnSpc>
-                <a:spcPct val="160000"/>
-              </a:lnSpc>
-            </a:pPr>
-            <a:r>
-              <a:rPr sz="800" b="0" spc="-8">
-                <a:solidFill>
-                  <a:srgbClr val="AEB4BA"/>
-                </a:solidFill>
-                <a:latin typeface="Pretendard"/>
-                <a:latin typeface="Pretendard"/>
-                <a:ea typeface="Pretendard"/>
-                <a:cs typeface="Pretendard"/>
-              </a:rPr>
-              <a:t>다이슨</a:t>
-            </a:r>
-          </a:p>
-        </p:txBody>
-      </p:sp>
-      <p:sp>
-        <p:nvSpPr>
-          <p:cNvPr id="15" name="Rounded Rectangle 14"/>
-          <p:cNvSpPr/>
-          <p:nvPr/>
-        </p:nvSpPr>
-        <p:spPr>
-          <a:xfrm>
-            <a:off x="7239000" y="2984500"/>
-            <a:ext cx="2032000" cy="889000"/>
-          </a:xfrm>
-          <a:prstGeom prst="roundRect">
-            <a:avLst>
-              <a:gd name="adj" fmla="val 7142"/>
-            </a:avLst>
-          </a:prstGeom>
-          <a:solidFill>
-            <a:srgbClr val="F7F8FA"/>
-          </a:solidFill>
-          <a:ln w="6350">
-            <a:solidFill>
-              <a:srgbClr val="EDEFF2"/>
-            </a:solidFill>
-          </a:ln>
-          <a:effectLst/>
-        </p:spPr>
-        <p:style>
-          <a:lnRef idx="1">
-            <a:schemeClr val="accent1"/>
-          </a:lnRef>
-          <a:fillRef idx="3">
-            <a:schemeClr val="accent1"/>
-          </a:fillRef>
-          <a:effectRef idx="2">
-            <a:schemeClr val="accent1"/>
-          </a:effectRef>
-          <a:fontRef idx="minor">
-            <a:schemeClr val="lt1"/>
-          </a:fontRef>
-        </p:style>
-        <p:txBody>
-          <a:bodyPr rtlCol="0" anchor="ctr"/>
-          <a:lstStyle/>
-          <a:p>
-            <a:pPr algn="ctr"/>
-          </a:p>
-        </p:txBody>
-      </p:sp>
-      <p:sp>
-        <p:nvSpPr>
-          <p:cNvPr id="16" name="TextBox 15"/>
-          <p:cNvSpPr txBox="1"/>
-          <p:nvPr/>
-        </p:nvSpPr>
-        <p:spPr>
-          <a:xfrm>
-            <a:off x="7315200" y="3347720"/>
-            <a:ext cx="1879600" cy="213360"/>
-          </a:xfrm>
-          <a:prstGeom prst="rect">
-            <a:avLst/>
-          </a:prstGeom>
-          <a:noFill/>
-        </p:spPr>
-        <p:txBody>
-          <a:bodyPr wrap="square" lIns="0" rIns="0" tIns="0" bIns="0" anchor="t">
-            <a:spAutoFit/>
-          </a:bodyPr>
-          <a:lstStyle/>
-          <a:p>
-            <a:pPr algn="ctr">
-              <a:lnSpc>
-                <a:spcPct val="160000"/>
-              </a:lnSpc>
-            </a:pPr>
-            <a:r>
-              <a:rPr sz="800" b="0" spc="-8">
-                <a:solidFill>
-                  <a:srgbClr val="AEB4BA"/>
-                </a:solidFill>
-                <a:latin typeface="Pretendard"/>
-                <a:latin typeface="Pretendard"/>
-                <a:ea typeface="Pretendard"/>
-                <a:cs typeface="Pretendard"/>
-              </a:rPr>
-              <a:t>메르세데스 벤츠</a:t>
-            </a:r>
-          </a:p>
-        </p:txBody>
-      </p:sp>
-      <p:sp>
-        <p:nvSpPr>
-          <p:cNvPr id="17" name="Rounded Rectangle 16"/>
-          <p:cNvSpPr/>
-          <p:nvPr/>
-        </p:nvSpPr>
-        <p:spPr>
-          <a:xfrm>
-            <a:off x="9398000" y="2984500"/>
-            <a:ext cx="2032000" cy="889000"/>
-          </a:xfrm>
-          <a:prstGeom prst="roundRect">
-            <a:avLst>
-              <a:gd name="adj" fmla="val 7142"/>
-            </a:avLst>
-          </a:prstGeom>
-          <a:solidFill>
-            <a:srgbClr val="F7F8FA"/>
-          </a:solidFill>
-          <a:ln w="6350">
-            <a:solidFill>
-              <a:srgbClr val="EDEFF2"/>
-            </a:solidFill>
-          </a:ln>
-          <a:effectLst/>
-        </p:spPr>
-        <p:style>
-          <a:lnRef idx="1">
-            <a:schemeClr val="accent1"/>
-          </a:lnRef>
-          <a:fillRef idx="3">
-            <a:schemeClr val="accent1"/>
-          </a:fillRef>
-          <a:effectRef idx="2">
-            <a:schemeClr val="accent1"/>
-          </a:effectRef>
-          <a:fontRef idx="minor">
-            <a:schemeClr val="lt1"/>
-          </a:fontRef>
-        </p:style>
-        <p:txBody>
-          <a:bodyPr rtlCol="0" anchor="ctr"/>
-          <a:lstStyle/>
-          <a:p>
-            <a:pPr algn="ctr"/>
-          </a:p>
-        </p:txBody>
-      </p:sp>
-      <p:sp>
-        <p:nvSpPr>
-          <p:cNvPr id="18" name="TextBox 17"/>
-          <p:cNvSpPr txBox="1"/>
-          <p:nvPr/>
-        </p:nvSpPr>
-        <p:spPr>
-          <a:xfrm>
-            <a:off x="9474200" y="3347720"/>
-            <a:ext cx="1879600" cy="213360"/>
-          </a:xfrm>
-          <a:prstGeom prst="rect">
-            <a:avLst/>
-          </a:prstGeom>
-          <a:noFill/>
-        </p:spPr>
-        <p:txBody>
-          <a:bodyPr wrap="square" lIns="0" rIns="0" tIns="0" bIns="0" anchor="t">
-            <a:spAutoFit/>
-          </a:bodyPr>
-          <a:lstStyle/>
-          <a:p>
-            <a:pPr algn="ctr">
-              <a:lnSpc>
-                <a:spcPct val="160000"/>
-              </a:lnSpc>
-            </a:pPr>
-            <a:r>
-              <a:rPr sz="800" b="0" spc="-8">
-                <a:solidFill>
-                  <a:srgbClr val="AEB4BA"/>
-                </a:solidFill>
-                <a:latin typeface="Pretendard"/>
-                <a:latin typeface="Pretendard"/>
-                <a:ea typeface="Pretendard"/>
-                <a:cs typeface="Pretendard"/>
-              </a:rPr>
-              <a:t>현대</a:t>
-            </a:r>
-          </a:p>
-        </p:txBody>
-      </p:sp>
-      <p:sp>
-        <p:nvSpPr>
-          <p:cNvPr id="19" name="Rounded Rectangle 18"/>
-          <p:cNvSpPr/>
-          <p:nvPr/>
-        </p:nvSpPr>
-        <p:spPr>
-          <a:xfrm>
-            <a:off x="762000" y="4000500"/>
-            <a:ext cx="2032000" cy="889000"/>
-          </a:xfrm>
-          <a:prstGeom prst="roundRect">
-            <a:avLst>
-              <a:gd name="adj" fmla="val 7142"/>
-            </a:avLst>
-          </a:prstGeom>
-          <a:solidFill>
-            <a:srgbClr val="F7F8FA"/>
-          </a:solidFill>
-          <a:ln w="6350">
-            <a:solidFill>
-              <a:srgbClr val="EDEFF2"/>
-            </a:solidFill>
-          </a:ln>
-          <a:effectLst/>
-        </p:spPr>
-        <p:style>
-          <a:lnRef idx="1">
-            <a:schemeClr val="accent1"/>
-          </a:lnRef>
-          <a:fillRef idx="3">
-            <a:schemeClr val="accent1"/>
-          </a:fillRef>
-          <a:effectRef idx="2">
-            <a:schemeClr val="accent1"/>
-          </a:effectRef>
-          <a:fontRef idx="minor">
-            <a:schemeClr val="lt1"/>
-          </a:fontRef>
-        </p:style>
-        <p:txBody>
-          <a:bodyPr rtlCol="0" anchor="ctr"/>
-          <a:lstStyle/>
-          <a:p>
-            <a:pPr algn="ctr"/>
-          </a:p>
-        </p:txBody>
-      </p:sp>
-      <p:sp>
-        <p:nvSpPr>
-          <p:cNvPr id="20" name="TextBox 19"/>
-          <p:cNvSpPr txBox="1"/>
-          <p:nvPr/>
-        </p:nvSpPr>
-        <p:spPr>
-          <a:xfrm>
-            <a:off x="838200" y="4363720"/>
-            <a:ext cx="1879600" cy="213360"/>
-          </a:xfrm>
-          <a:prstGeom prst="rect">
-            <a:avLst/>
-          </a:prstGeom>
-          <a:noFill/>
-        </p:spPr>
-        <p:txBody>
-          <a:bodyPr wrap="square" lIns="0" rIns="0" tIns="0" bIns="0" anchor="t">
-            <a:spAutoFit/>
-          </a:bodyPr>
-          <a:lstStyle/>
-          <a:p>
-            <a:pPr algn="ctr">
-              <a:lnSpc>
-                <a:spcPct val="160000"/>
-              </a:lnSpc>
-            </a:pPr>
-            <a:r>
-              <a:rPr sz="800" b="0" spc="-8">
-                <a:solidFill>
-                  <a:srgbClr val="AEB4BA"/>
-                </a:solidFill>
-                <a:latin typeface="Pretendard"/>
-                <a:latin typeface="Pretendard"/>
-                <a:ea typeface="Pretendard"/>
-                <a:cs typeface="Pretendard"/>
-              </a:rPr>
-              <a:t>삼성</a:t>
-            </a:r>
-          </a:p>
-        </p:txBody>
-      </p:sp>
-      <p:sp>
-        <p:nvSpPr>
-          <p:cNvPr id="21" name="Rounded Rectangle 20"/>
-          <p:cNvSpPr/>
-          <p:nvPr/>
-        </p:nvSpPr>
-        <p:spPr>
-          <a:xfrm>
-            <a:off x="2921000" y="4000500"/>
-            <a:ext cx="2032000" cy="889000"/>
-          </a:xfrm>
-          <a:prstGeom prst="roundRect">
-            <a:avLst>
-              <a:gd name="adj" fmla="val 7142"/>
-            </a:avLst>
-          </a:prstGeom>
-          <a:solidFill>
-            <a:srgbClr val="F7F8FA"/>
-          </a:solidFill>
-          <a:ln w="6350">
-            <a:solidFill>
-              <a:srgbClr val="EDEFF2"/>
-            </a:solidFill>
-          </a:ln>
-          <a:effectLst/>
-        </p:spPr>
-        <p:style>
-          <a:lnRef idx="1">
-            <a:schemeClr val="accent1"/>
-          </a:lnRef>
-          <a:fillRef idx="3">
-            <a:schemeClr val="accent1"/>
-          </a:fillRef>
-          <a:effectRef idx="2">
-            <a:schemeClr val="accent1"/>
-          </a:effectRef>
-          <a:fontRef idx="minor">
-            <a:schemeClr val="lt1"/>
-          </a:fontRef>
-        </p:style>
-        <p:txBody>
-          <a:bodyPr rtlCol="0" anchor="ctr"/>
-          <a:lstStyle/>
-          <a:p>
-            <a:pPr algn="ctr"/>
-          </a:p>
-        </p:txBody>
-      </p:sp>
-      <p:sp>
-        <p:nvSpPr>
-          <p:cNvPr id="22" name="TextBox 21"/>
-          <p:cNvSpPr txBox="1"/>
-          <p:nvPr/>
-        </p:nvSpPr>
-        <p:spPr>
-          <a:xfrm>
-            <a:off x="2997200" y="4363720"/>
-            <a:ext cx="1879600" cy="213360"/>
-          </a:xfrm>
-          <a:prstGeom prst="rect">
-            <a:avLst/>
-          </a:prstGeom>
-          <a:noFill/>
-        </p:spPr>
-        <p:txBody>
-          <a:bodyPr wrap="square" lIns="0" rIns="0" tIns="0" bIns="0" anchor="t">
-            <a:spAutoFit/>
-          </a:bodyPr>
-          <a:lstStyle/>
-          <a:p>
-            <a:pPr algn="ctr">
-              <a:lnSpc>
-                <a:spcPct val="160000"/>
-              </a:lnSpc>
-            </a:pPr>
-            <a:r>
-              <a:rPr sz="800" b="0" spc="-8">
-                <a:solidFill>
-                  <a:srgbClr val="AEB4BA"/>
-                </a:solidFill>
-                <a:latin typeface="Pretendard"/>
-                <a:latin typeface="Pretendard"/>
-                <a:ea typeface="Pretendard"/>
-                <a:cs typeface="Pretendard"/>
-              </a:rPr>
-              <a:t>삼다수</a:t>
-            </a:r>
-          </a:p>
-        </p:txBody>
-      </p:sp>
-      <p:sp>
-        <p:nvSpPr>
-          <p:cNvPr id="23" name="Rounded Rectangle 22"/>
-          <p:cNvSpPr/>
-          <p:nvPr/>
-        </p:nvSpPr>
-        <p:spPr>
-          <a:xfrm>
-            <a:off x="5080000" y="4000500"/>
-            <a:ext cx="2032000" cy="889000"/>
-          </a:xfrm>
-          <a:prstGeom prst="roundRect">
-            <a:avLst>
-              <a:gd name="adj" fmla="val 7142"/>
-            </a:avLst>
-          </a:prstGeom>
-          <a:solidFill>
-            <a:srgbClr val="F7F8FA"/>
-          </a:solidFill>
-          <a:ln w="6350">
-            <a:solidFill>
-              <a:srgbClr val="EDEFF2"/>
-            </a:solidFill>
-          </a:ln>
-          <a:effectLst/>
-        </p:spPr>
-        <p:style>
-          <a:lnRef idx="1">
-            <a:schemeClr val="accent1"/>
-          </a:lnRef>
-          <a:fillRef idx="3">
-            <a:schemeClr val="accent1"/>
-          </a:fillRef>
-          <a:effectRef idx="2">
-            <a:schemeClr val="accent1"/>
-          </a:effectRef>
-          <a:fontRef idx="minor">
-            <a:schemeClr val="lt1"/>
-          </a:fontRef>
-        </p:style>
-        <p:txBody>
-          <a:bodyPr rtlCol="0" anchor="ctr"/>
-          <a:lstStyle/>
-          <a:p>
-            <a:pPr algn="ctr"/>
-          </a:p>
-        </p:txBody>
-      </p:sp>
-      <p:sp>
-        <p:nvSpPr>
-          <p:cNvPr id="24" name="TextBox 23"/>
-          <p:cNvSpPr txBox="1"/>
-          <p:nvPr/>
-        </p:nvSpPr>
-        <p:spPr>
-          <a:xfrm>
-            <a:off x="5156200" y="4363720"/>
-            <a:ext cx="1879600" cy="213360"/>
-          </a:xfrm>
-          <a:prstGeom prst="rect">
-            <a:avLst/>
-          </a:prstGeom>
-          <a:noFill/>
-        </p:spPr>
-        <p:txBody>
-          <a:bodyPr wrap="square" lIns="0" rIns="0" tIns="0" bIns="0" anchor="t">
-            <a:spAutoFit/>
-          </a:bodyPr>
-          <a:lstStyle/>
-          <a:p>
-            <a:pPr algn="ctr">
-              <a:lnSpc>
-                <a:spcPct val="160000"/>
-              </a:lnSpc>
-            </a:pPr>
-            <a:r>
-              <a:rPr sz="800" b="0" spc="-8">
-                <a:solidFill>
-                  <a:srgbClr val="AEB4BA"/>
-                </a:solidFill>
-                <a:latin typeface="Pretendard"/>
-                <a:latin typeface="Pretendard"/>
-                <a:ea typeface="Pretendard"/>
-                <a:cs typeface="Pretendard"/>
-              </a:rPr>
-              <a:t>올리브영</a:t>
-            </a:r>
-          </a:p>
-        </p:txBody>
-      </p:sp>
-      <p:sp>
-        <p:nvSpPr>
-          <p:cNvPr id="25" name="Rounded Rectangle 24"/>
-          <p:cNvSpPr/>
-          <p:nvPr/>
-        </p:nvSpPr>
-        <p:spPr>
-          <a:xfrm>
-            <a:off x="7239000" y="4000500"/>
-            <a:ext cx="2032000" cy="889000"/>
-          </a:xfrm>
-          <a:prstGeom prst="roundRect">
-            <a:avLst>
-              <a:gd name="adj" fmla="val 7142"/>
-            </a:avLst>
-          </a:prstGeom>
-          <a:solidFill>
-            <a:srgbClr val="F7F8FA"/>
-          </a:solidFill>
-          <a:ln w="6350">
-            <a:solidFill>
-              <a:srgbClr val="EDEFF2"/>
-            </a:solidFill>
-          </a:ln>
-          <a:effectLst/>
-        </p:spPr>
-        <p:style>
-          <a:lnRef idx="1">
-            <a:schemeClr val="accent1"/>
-          </a:lnRef>
-          <a:fillRef idx="3">
-            <a:schemeClr val="accent1"/>
-          </a:fillRef>
-          <a:effectRef idx="2">
-            <a:schemeClr val="accent1"/>
-          </a:effectRef>
-          <a:fontRef idx="minor">
-            <a:schemeClr val="lt1"/>
-          </a:fontRef>
-        </p:style>
-        <p:txBody>
-          <a:bodyPr rtlCol="0" anchor="ctr"/>
-          <a:lstStyle/>
-          <a:p>
-            <a:pPr algn="ctr"/>
-          </a:p>
-        </p:txBody>
-      </p:sp>
-      <p:sp>
-        <p:nvSpPr>
-          <p:cNvPr id="26" name="TextBox 25"/>
-          <p:cNvSpPr txBox="1"/>
-          <p:nvPr/>
-        </p:nvSpPr>
-        <p:spPr>
-          <a:xfrm>
-            <a:off x="7315200" y="4363720"/>
-            <a:ext cx="1879600" cy="213360"/>
-          </a:xfrm>
-          <a:prstGeom prst="rect">
-            <a:avLst/>
-          </a:prstGeom>
-          <a:noFill/>
-        </p:spPr>
-        <p:txBody>
-          <a:bodyPr wrap="square" lIns="0" rIns="0" tIns="0" bIns="0" anchor="t">
-            <a:spAutoFit/>
-          </a:bodyPr>
-          <a:lstStyle/>
-          <a:p>
-            <a:pPr algn="ctr">
-              <a:lnSpc>
-                <a:spcPct val="160000"/>
-              </a:lnSpc>
-            </a:pPr>
-            <a:r>
-              <a:rPr sz="800" b="0" spc="-8">
-                <a:solidFill>
-                  <a:srgbClr val="AEB4BA"/>
-                </a:solidFill>
-                <a:latin typeface="Pretendard"/>
-                <a:latin typeface="Pretendard"/>
-                <a:ea typeface="Pretendard"/>
-                <a:cs typeface="Pretendard"/>
-              </a:rPr>
-              <a:t>티쏘</a:t>
-            </a:r>
-          </a:p>
-        </p:txBody>
-      </p:sp>
-      <p:sp>
-        <p:nvSpPr>
-          <p:cNvPr id="27" name="Rounded Rectangle 26"/>
-          <p:cNvSpPr/>
-          <p:nvPr/>
-        </p:nvSpPr>
-        <p:spPr>
-          <a:xfrm>
-            <a:off x="9398000" y="4000500"/>
-            <a:ext cx="2032000" cy="889000"/>
-          </a:xfrm>
-          <a:prstGeom prst="roundRect">
-            <a:avLst>
-              <a:gd name="adj" fmla="val 7142"/>
-            </a:avLst>
-          </a:prstGeom>
-          <a:solidFill>
-            <a:srgbClr val="F7F8FA"/>
-          </a:solidFill>
-          <a:ln w="6350">
-            <a:solidFill>
-              <a:srgbClr val="EDEFF2"/>
-            </a:solidFill>
-          </a:ln>
-          <a:effectLst/>
-        </p:spPr>
-        <p:style>
-          <a:lnRef idx="1">
-            <a:schemeClr val="accent1"/>
-          </a:lnRef>
-          <a:fillRef idx="3">
-            <a:schemeClr val="accent1"/>
-          </a:fillRef>
-          <a:effectRef idx="2">
-            <a:schemeClr val="accent1"/>
-          </a:effectRef>
-          <a:fontRef idx="minor">
-            <a:schemeClr val="lt1"/>
-          </a:fontRef>
-        </p:style>
-        <p:txBody>
-          <a:bodyPr rtlCol="0" anchor="ctr"/>
-          <a:lstStyle/>
-          <a:p>
-            <a:pPr algn="ctr"/>
-          </a:p>
-        </p:txBody>
-      </p:sp>
-      <p:sp>
-        <p:nvSpPr>
-          <p:cNvPr id="28" name="TextBox 27"/>
-          <p:cNvSpPr txBox="1"/>
-          <p:nvPr/>
-        </p:nvSpPr>
-        <p:spPr>
-          <a:xfrm>
-            <a:off x="9474200" y="4363720"/>
-            <a:ext cx="1879600" cy="213360"/>
-          </a:xfrm>
-          <a:prstGeom prst="rect">
-            <a:avLst/>
-          </a:prstGeom>
-          <a:noFill/>
-        </p:spPr>
-        <p:txBody>
-          <a:bodyPr wrap="square" lIns="0" rIns="0" tIns="0" bIns="0" anchor="t">
-            <a:spAutoFit/>
-          </a:bodyPr>
-          <a:lstStyle/>
-          <a:p>
-            <a:pPr algn="ctr">
-              <a:lnSpc>
-                <a:spcPct val="160000"/>
-              </a:lnSpc>
-            </a:pPr>
-            <a:r>
-              <a:rPr sz="800" b="0" spc="-8">
-                <a:solidFill>
-                  <a:srgbClr val="AEB4BA"/>
-                </a:solidFill>
-                <a:latin typeface="Pretendard"/>
-                <a:latin typeface="Pretendard"/>
-                <a:ea typeface="Pretendard"/>
-                <a:cs typeface="Pretendard"/>
-              </a:rPr>
-              <a:t>마이크로소프트</a:t>
-            </a:r>
-          </a:p>
-        </p:txBody>
-      </p:sp>
-      <p:sp>
-        <p:nvSpPr>
-          <p:cNvPr id="29" name="Rounded Rectangle 28"/>
-          <p:cNvSpPr/>
-          <p:nvPr/>
-        </p:nvSpPr>
-        <p:spPr>
-          <a:xfrm>
-            <a:off x="762000" y="5016500"/>
-            <a:ext cx="2032000" cy="889000"/>
-          </a:xfrm>
-          <a:prstGeom prst="roundRect">
-            <a:avLst>
-              <a:gd name="adj" fmla="val 7142"/>
-            </a:avLst>
-          </a:prstGeom>
-          <a:solidFill>
-            <a:srgbClr val="F7F8FA"/>
-          </a:solidFill>
-          <a:ln w="6350">
-            <a:solidFill>
-              <a:srgbClr val="EDEFF2"/>
-            </a:solidFill>
-          </a:ln>
-          <a:effectLst/>
-        </p:spPr>
-        <p:style>
-          <a:lnRef idx="1">
-            <a:schemeClr val="accent1"/>
-          </a:lnRef>
-          <a:fillRef idx="3">
-            <a:schemeClr val="accent1"/>
-          </a:fillRef>
-          <a:effectRef idx="2">
-            <a:schemeClr val="accent1"/>
-          </a:effectRef>
-          <a:fontRef idx="minor">
-            <a:schemeClr val="lt1"/>
-          </a:fontRef>
-        </p:style>
-        <p:txBody>
-          <a:bodyPr rtlCol="0" anchor="ctr"/>
-          <a:lstStyle/>
-          <a:p>
-            <a:pPr algn="ctr"/>
-          </a:p>
-        </p:txBody>
-      </p:sp>
-      <p:sp>
-        <p:nvSpPr>
-          <p:cNvPr id="30" name="TextBox 29"/>
-          <p:cNvSpPr txBox="1"/>
-          <p:nvPr/>
-        </p:nvSpPr>
-        <p:spPr>
-          <a:xfrm>
-            <a:off x="838200" y="5379720"/>
-            <a:ext cx="1879600" cy="213360"/>
-          </a:xfrm>
-          <a:prstGeom prst="rect">
-            <a:avLst/>
-          </a:prstGeom>
-          <a:noFill/>
-        </p:spPr>
-        <p:txBody>
-          <a:bodyPr wrap="square" lIns="0" rIns="0" tIns="0" bIns="0" anchor="t">
-            <a:spAutoFit/>
-          </a:bodyPr>
-          <a:lstStyle/>
-          <a:p>
-            <a:pPr algn="ctr">
-              <a:lnSpc>
-                <a:spcPct val="160000"/>
-              </a:lnSpc>
-            </a:pPr>
-            <a:r>
-              <a:rPr sz="800" b="0" spc="-8">
-                <a:solidFill>
-                  <a:srgbClr val="AEB4BA"/>
-                </a:solidFill>
-                <a:latin typeface="Pretendard"/>
-                <a:latin typeface="Pretendard"/>
-                <a:ea typeface="Pretendard"/>
-                <a:cs typeface="Pretendard"/>
-              </a:rPr>
-              <a:t>삼양</a:t>
-            </a:r>
-          </a:p>
-        </p:txBody>
-      </p:sp>
-      <p:sp>
-        <p:nvSpPr>
-          <p:cNvPr id="31" name="Rounded Rectangle 30"/>
-          <p:cNvSpPr/>
-          <p:nvPr/>
-        </p:nvSpPr>
-        <p:spPr>
-          <a:xfrm>
-            <a:off x="2921000" y="5016500"/>
-            <a:ext cx="2032000" cy="889000"/>
-          </a:xfrm>
-          <a:prstGeom prst="roundRect">
-            <a:avLst>
-              <a:gd name="adj" fmla="val 7142"/>
-            </a:avLst>
-          </a:prstGeom>
-          <a:solidFill>
-            <a:srgbClr val="F7F8FA"/>
-          </a:solidFill>
-          <a:ln w="6350">
-            <a:solidFill>
-              <a:srgbClr val="EDEFF2"/>
-            </a:solidFill>
-          </a:ln>
-          <a:effectLst/>
-        </p:spPr>
-        <p:style>
-          <a:lnRef idx="1">
-            <a:schemeClr val="accent1"/>
-          </a:lnRef>
-          <a:fillRef idx="3">
-            <a:schemeClr val="accent1"/>
-          </a:fillRef>
-          <a:effectRef idx="2">
-            <a:schemeClr val="accent1"/>
-          </a:effectRef>
-          <a:fontRef idx="minor">
-            <a:schemeClr val="lt1"/>
-          </a:fontRef>
-        </p:style>
-        <p:txBody>
-          <a:bodyPr rtlCol="0" anchor="ctr"/>
-          <a:lstStyle/>
-          <a:p>
-            <a:pPr algn="ctr"/>
-          </a:p>
-        </p:txBody>
-      </p:sp>
-      <p:sp>
-        <p:nvSpPr>
-          <p:cNvPr id="32" name="TextBox 31"/>
-          <p:cNvSpPr txBox="1"/>
-          <p:nvPr/>
-        </p:nvSpPr>
-        <p:spPr>
-          <a:xfrm>
-            <a:off x="2997200" y="5379720"/>
-            <a:ext cx="1879600" cy="213360"/>
-          </a:xfrm>
-          <a:prstGeom prst="rect">
-            <a:avLst/>
-          </a:prstGeom>
-          <a:noFill/>
-        </p:spPr>
-        <p:txBody>
-          <a:bodyPr wrap="square" lIns="0" rIns="0" tIns="0" bIns="0" anchor="t">
-            <a:spAutoFit/>
-          </a:bodyPr>
-          <a:lstStyle/>
-          <a:p>
-            <a:pPr algn="ctr">
-              <a:lnSpc>
-                <a:spcPct val="160000"/>
-              </a:lnSpc>
-            </a:pPr>
-            <a:r>
-              <a:rPr sz="800" b="0" spc="-8">
-                <a:solidFill>
-                  <a:srgbClr val="AEB4BA"/>
-                </a:solidFill>
-                <a:latin typeface="Pretendard"/>
-                <a:latin typeface="Pretendard"/>
-                <a:ea typeface="Pretendard"/>
-                <a:cs typeface="Pretendard"/>
-              </a:rPr>
-              <a:t>춘천시</a:t>
-            </a:r>
-          </a:p>
-        </p:txBody>
-      </p:sp>
-      <p:sp>
-        <p:nvSpPr>
-          <p:cNvPr id="33" name="Rounded Rectangle 32"/>
-          <p:cNvSpPr/>
-          <p:nvPr/>
-        </p:nvSpPr>
-        <p:spPr>
-          <a:xfrm>
-            <a:off x="5080000" y="5016500"/>
-            <a:ext cx="2032000" cy="889000"/>
-          </a:xfrm>
-          <a:prstGeom prst="roundRect">
-            <a:avLst>
-              <a:gd name="adj" fmla="val 7142"/>
-            </a:avLst>
-          </a:prstGeom>
-          <a:solidFill>
-            <a:srgbClr val="F7F8FA"/>
-          </a:solidFill>
-          <a:ln w="6350">
-            <a:solidFill>
-              <a:srgbClr val="EDEFF2"/>
-            </a:solidFill>
-          </a:ln>
-          <a:effectLst/>
-        </p:spPr>
-        <p:style>
-          <a:lnRef idx="1">
-            <a:schemeClr val="accent1"/>
-          </a:lnRef>
-          <a:fillRef idx="3">
-            <a:schemeClr val="accent1"/>
-          </a:fillRef>
-          <a:effectRef idx="2">
-            <a:schemeClr val="accent1"/>
-          </a:effectRef>
-          <a:fontRef idx="minor">
-            <a:schemeClr val="lt1"/>
-          </a:fontRef>
-        </p:style>
-        <p:txBody>
-          <a:bodyPr rtlCol="0" anchor="ctr"/>
-          <a:lstStyle/>
-          <a:p>
-            <a:pPr algn="ctr"/>
-          </a:p>
-        </p:txBody>
-      </p:sp>
-      <p:sp>
-        <p:nvSpPr>
-          <p:cNvPr id="34" name="TextBox 33"/>
-          <p:cNvSpPr txBox="1"/>
-          <p:nvPr/>
-        </p:nvSpPr>
-        <p:spPr>
-          <a:xfrm>
-            <a:off x="5156200" y="5379720"/>
-            <a:ext cx="1879600" cy="213360"/>
-          </a:xfrm>
-          <a:prstGeom prst="rect">
-            <a:avLst/>
-          </a:prstGeom>
-          <a:noFill/>
-        </p:spPr>
-        <p:txBody>
-          <a:bodyPr wrap="square" lIns="0" rIns="0" tIns="0" bIns="0" anchor="t">
-            <a:spAutoFit/>
-          </a:bodyPr>
-          <a:lstStyle/>
-          <a:p>
-            <a:pPr algn="ctr">
-              <a:lnSpc>
-                <a:spcPct val="160000"/>
-              </a:lnSpc>
-            </a:pPr>
-            <a:r>
-              <a:rPr sz="800" b="0" spc="-8">
-                <a:solidFill>
-                  <a:srgbClr val="AEB4BA"/>
-                </a:solidFill>
-                <a:latin typeface="Pretendard"/>
-                <a:latin typeface="Pretendard"/>
-                <a:ea typeface="Pretendard"/>
-                <a:cs typeface="Pretendard"/>
-              </a:rPr>
-              <a:t>곡성군</a:t>
-            </a:r>
-          </a:p>
-        </p:txBody>
-      </p:sp>
-      <p:sp>
-        <p:nvSpPr>
-          <p:cNvPr id="35" name="Rounded Rectangle 34"/>
-          <p:cNvSpPr/>
-          <p:nvPr/>
-        </p:nvSpPr>
-        <p:spPr>
-          <a:xfrm>
-            <a:off x="7239000" y="5016500"/>
-            <a:ext cx="2032000" cy="889000"/>
-          </a:xfrm>
-          <a:prstGeom prst="roundRect">
-            <a:avLst>
-              <a:gd name="adj" fmla="val 7142"/>
-            </a:avLst>
-          </a:prstGeom>
-          <a:solidFill>
-            <a:srgbClr val="F7F8FA"/>
-          </a:solidFill>
-          <a:ln w="6350">
-            <a:solidFill>
-              <a:srgbClr val="EDEFF2"/>
-            </a:solidFill>
-          </a:ln>
-          <a:effectLst/>
-        </p:spPr>
-        <p:style>
-          <a:lnRef idx="1">
-            <a:schemeClr val="accent1"/>
-          </a:lnRef>
-          <a:fillRef idx="3">
-            <a:schemeClr val="accent1"/>
-          </a:fillRef>
-          <a:effectRef idx="2">
-            <a:schemeClr val="accent1"/>
-          </a:effectRef>
-          <a:fontRef idx="minor">
-            <a:schemeClr val="lt1"/>
-          </a:fontRef>
-        </p:style>
-        <p:txBody>
-          <a:bodyPr rtlCol="0" anchor="ctr"/>
-          <a:lstStyle/>
-          <a:p>
-            <a:pPr algn="ctr"/>
-          </a:p>
-        </p:txBody>
-      </p:sp>
-      <p:sp>
-        <p:nvSpPr>
-          <p:cNvPr id="36" name="TextBox 35"/>
-          <p:cNvSpPr txBox="1"/>
-          <p:nvPr/>
-        </p:nvSpPr>
-        <p:spPr>
-          <a:xfrm>
-            <a:off x="7315200" y="5379720"/>
-            <a:ext cx="1879600" cy="213360"/>
-          </a:xfrm>
-          <a:prstGeom prst="rect">
-            <a:avLst/>
-          </a:prstGeom>
-          <a:noFill/>
-        </p:spPr>
-        <p:txBody>
-          <a:bodyPr wrap="square" lIns="0" rIns="0" tIns="0" bIns="0" anchor="t">
-            <a:spAutoFit/>
-          </a:bodyPr>
-          <a:lstStyle/>
-          <a:p>
-            <a:pPr algn="ctr">
-              <a:lnSpc>
-                <a:spcPct val="160000"/>
-              </a:lnSpc>
-            </a:pPr>
-            <a:r>
-              <a:rPr sz="800" b="0" spc="-8">
-                <a:solidFill>
-                  <a:srgbClr val="AEB4BA"/>
-                </a:solidFill>
-                <a:latin typeface="Pretendard"/>
-                <a:latin typeface="Pretendard"/>
-                <a:ea typeface="Pretendard"/>
-                <a:cs typeface="Pretendard"/>
-              </a:rPr>
-              <a:t>고양국제박람회재단</a:t>
-            </a:r>
-          </a:p>
-        </p:txBody>
-      </p:sp>
+      <p:pic>
+        <p:nvPicPr>
+          <p:cNvPr id="9" name="Picture 8" descr="logogrid.png"/>
+          <p:cNvPicPr>
+            <a:picLocks noChangeAspect="1"/>
+          </p:cNvPicPr>
+          <p:nvPr/>
+        </p:nvPicPr>
+        <p:blipFill>
+          <a:blip r:embed="rId2"/>
+          <a:stretch>
+            <a:fillRect/>
+          </a:stretch>
+        </p:blipFill>
+        <p:spPr>
+          <a:xfrm>
+            <a:off x="762000" y="2800350"/>
+            <a:ext cx="10668000" cy="2749550"/>
+          </a:xfrm>
+          <a:prstGeom prst="rect">
+            <a:avLst/>
+          </a:prstGeom>
+        </p:spPr>
+      </p:pic>
     </p:spTree>
   </p:cSld>
   <p:clrMapOvr>

</xml_diff>